<commit_message>
Fix live Google Slides bugs from the connector test
CENTERED_TITLE, skip deleteText on empty shapes, Archivo weight 300
instead of Archivo Light, Paper type on the title slide, always draw
the footer at the 0.50 in inset, two-phase creates/fills, and a
drawn Section Title rail that matches the PPTX strip.

Co-authored-by: Audge <audr3x@users.noreply.github.com>
</commit_message>
<xml_diff>
--- a/examples/example-deck.pptx
+++ b/examples/example-deck.pptx
@@ -7144,7 +7144,7 @@
         </p:nvSpPr>
         <p:spPr>
           <a:xfrm>
-            <a:off x="27432" y="4818888"/>
+            <a:off x="457200" y="4818888"/>
             <a:ext cx="3086100" cy="274320"/>
           </a:xfrm>
           <a:prstGeom prst="rect">
@@ -7358,7 +7358,7 @@
         </p:nvSpPr>
         <p:spPr>
           <a:xfrm>
-            <a:off x="27432" y="4818888"/>
+            <a:off x="457200" y="4818888"/>
             <a:ext cx="3086100" cy="274320"/>
           </a:xfrm>
           <a:prstGeom prst="rect">
@@ -7430,7 +7430,7 @@
         </p:nvSpPr>
         <p:spPr>
           <a:xfrm>
-            <a:off x="27432" y="4818888"/>
+            <a:off x="457200" y="4818888"/>
             <a:ext cx="3086100" cy="274320"/>
           </a:xfrm>
           <a:prstGeom prst="rect">
@@ -7799,7 +7799,7 @@
         </p:nvSpPr>
         <p:spPr>
           <a:xfrm>
-            <a:off x="27432" y="4818888"/>
+            <a:off x="457200" y="4818888"/>
             <a:ext cx="3086100" cy="274320"/>
           </a:xfrm>
           <a:prstGeom prst="rect">
@@ -8422,7 +8422,7 @@
         </p:nvSpPr>
         <p:spPr>
           <a:xfrm>
-            <a:off x="27432" y="4818888"/>
+            <a:off x="457200" y="4818888"/>
             <a:ext cx="3086100" cy="274320"/>
           </a:xfrm>
           <a:prstGeom prst="rect">

</xml_diff>